<commit_message>
Updated, all materials implemented
</commit_message>
<xml_diff>
--- a/03-DOM-BOM-HTML-tushunchalari/DOM_BOM_Event_Taqdimot_YAKUNIY [Repaired].pptx
+++ b/03-DOM-BOM-HTML-tushunchalari/DOM_BOM_Event_Taqdimot_YAKUNIY [Repaired].pptx
@@ -1656,83 +1656,154 @@
           <a:bodyPr wrap="square" lIns="0" tIns="0" rIns="0" bIns="0" rtlCol="0" anchor="ctr"/>
           <a:lstStyle/>
           <a:p>
-            <a:pPr marL="0" indent="0">
+            <a:pPr>
               <a:lnSpc>
                 <a:spcPct val="105000"/>
               </a:lnSpc>
-              <a:buNone/>
-            </a:pPr>
-            <a:r>
-              <a:rPr lang="en-US" sz="4600" b="1" dirty="0">
-                <a:solidFill>
-                  <a:srgbClr val="FFFFFF"/>
-                </a:solidFill>
-                <a:latin typeface="Cambria" pitchFamily="34" charset="0"/>
-                <a:ea typeface="Cambria" pitchFamily="34" charset="-122"/>
-                <a:cs typeface="Cambria" pitchFamily="34" charset="-120"/>
-              </a:rPr>
-              <a:t>DOM, BOM va</a:t>
-            </a:r>
-            <a:endParaRPr lang="en-US" sz="4600" dirty="0"/>
-          </a:p>
-          <a:p>
-            <a:pPr marL="0" indent="0">
-              <a:lnSpc>
-                <a:spcPct val="105000"/>
-              </a:lnSpc>
-              <a:buNone/>
-            </a:pPr>
-            <a:r>
-              <a:rPr lang="en-US" sz="4600" b="1" dirty="0">
-                <a:solidFill>
-                  <a:srgbClr val="FFFFFF"/>
-                </a:solidFill>
-                <a:latin typeface="Cambria" pitchFamily="34" charset="0"/>
-                <a:ea typeface="Cambria" pitchFamily="34" charset="-122"/>
-                <a:cs typeface="Cambria" pitchFamily="34" charset="-120"/>
-              </a:rPr>
-              <a:t>Event'lar</a:t>
-            </a:r>
-            <a:endParaRPr lang="en-US" sz="4600" dirty="0"/>
-          </a:p>
-        </p:txBody>
-      </p:sp>
-      <p:sp>
-        <p:nvSpPr>
-          <p:cNvPr id="4" name="Text 2"/>
-          <p:cNvSpPr/>
-          <p:nvPr/>
-        </p:nvSpPr>
-        <p:spPr>
-          <a:xfrm>
-            <a:off x="731520" y="4160520"/>
-            <a:ext cx="10058400" cy="548640"/>
-          </a:xfrm>
-          <a:prstGeom prst="rect">
-            <a:avLst/>
-          </a:prstGeom>
-          <a:noFill/>
-          <a:ln/>
-        </p:spPr>
-        <p:txBody>
-          <a:bodyPr wrap="square" rtlCol="0" anchor="ctr"/>
-          <a:lstStyle/>
-          <a:p>
-            <a:pPr marL="0" indent="0">
-              <a:buNone/>
-            </a:pPr>
-            <a:r>
-              <a:rPr lang="en-US" sz="1800" i="1" dirty="0">
-                <a:solidFill>
-                  <a:srgbClr val="9BE8CE"/>
-                </a:solidFill>
-                <a:latin typeface="Calibri" pitchFamily="34" charset="0"/>
-                <a:ea typeface="Calibri" pitchFamily="34" charset="-122"/>
-                <a:cs typeface="Calibri" pitchFamily="34" charset="-120"/>
-              </a:rPr>
-              <a:t>HTML elementlarini JavaScript orqali boshqarish va hodisalar bilan ishlash</a:t>
-            </a:r>
-            <a:endParaRPr lang="en-US" sz="1800" dirty="0"/>
+            </a:pPr>
+            <a:r>
+              <a:rPr lang="en-US" sz="4500" dirty="0">
+                <a:solidFill>
+                  <a:schemeClr val="bg1"/>
+                </a:solidFill>
+              </a:rPr>
+              <a:t>DOM </a:t>
+            </a:r>
+            <a:r>
+              <a:rPr lang="en-US" sz="4500" dirty="0" err="1">
+                <a:solidFill>
+                  <a:schemeClr val="bg1"/>
+                </a:solidFill>
+              </a:rPr>
+              <a:t>va</a:t>
+            </a:r>
+            <a:r>
+              <a:rPr lang="en-US" sz="4500" dirty="0">
+                <a:solidFill>
+                  <a:schemeClr val="bg1"/>
+                </a:solidFill>
+              </a:rPr>
+              <a:t> BOM </a:t>
+            </a:r>
+            <a:r>
+              <a:rPr lang="en-US" sz="4500" dirty="0" err="1">
+                <a:solidFill>
+                  <a:schemeClr val="bg1"/>
+                </a:solidFill>
+              </a:rPr>
+              <a:t>tushunchalari</a:t>
+            </a:r>
+            <a:r>
+              <a:rPr lang="en-US" sz="4500" dirty="0">
+                <a:solidFill>
+                  <a:schemeClr val="bg1"/>
+                </a:solidFill>
+              </a:rPr>
+              <a:t>. HTML </a:t>
+            </a:r>
+            <a:r>
+              <a:rPr lang="en-US" sz="4500" dirty="0" err="1">
+                <a:solidFill>
+                  <a:schemeClr val="bg1"/>
+                </a:solidFill>
+              </a:rPr>
+              <a:t>elementlarini</a:t>
+            </a:r>
+            <a:r>
+              <a:rPr lang="en-US" sz="4500" dirty="0">
+                <a:solidFill>
+                  <a:schemeClr val="bg1"/>
+                </a:solidFill>
+              </a:rPr>
+              <a:t> JavaScript </a:t>
+            </a:r>
+            <a:r>
+              <a:rPr lang="en-US" sz="4500" dirty="0" err="1">
+                <a:solidFill>
+                  <a:schemeClr val="bg1"/>
+                </a:solidFill>
+              </a:rPr>
+              <a:t>orqali</a:t>
+            </a:r>
+            <a:r>
+              <a:rPr lang="en-US" sz="4500" dirty="0">
+                <a:solidFill>
+                  <a:schemeClr val="bg1"/>
+                </a:solidFill>
+              </a:rPr>
+              <a:t> </a:t>
+            </a:r>
+            <a:br>
+              <a:rPr lang="en-US" sz="4500" dirty="0">
+                <a:solidFill>
+                  <a:schemeClr val="bg1"/>
+                </a:solidFill>
+              </a:rPr>
+            </a:br>
+            <a:r>
+              <a:rPr lang="en-US" sz="4500" dirty="0" err="1">
+                <a:solidFill>
+                  <a:schemeClr val="bg1"/>
+                </a:solidFill>
+              </a:rPr>
+              <a:t>boshqarish</a:t>
+            </a:r>
+            <a:r>
+              <a:rPr lang="en-US" sz="4500" dirty="0">
+                <a:solidFill>
+                  <a:schemeClr val="bg1"/>
+                </a:solidFill>
+              </a:rPr>
+              <a:t>. </a:t>
+            </a:r>
+            <a:r>
+              <a:rPr lang="en-US" sz="4500" dirty="0" err="1">
+                <a:solidFill>
+                  <a:schemeClr val="bg1"/>
+                </a:solidFill>
+              </a:rPr>
+              <a:t>Hodisalar</a:t>
+            </a:r>
+            <a:r>
+              <a:rPr lang="en-US" sz="4500" dirty="0">
+                <a:solidFill>
+                  <a:schemeClr val="bg1"/>
+                </a:solidFill>
+              </a:rPr>
+              <a:t> (Events) </a:t>
+            </a:r>
+            <a:r>
+              <a:rPr lang="en-US" sz="4500" dirty="0" err="1">
+                <a:solidFill>
+                  <a:schemeClr val="bg1"/>
+                </a:solidFill>
+              </a:rPr>
+              <a:t>bilan</a:t>
+            </a:r>
+            <a:r>
+              <a:rPr lang="en-US" sz="4500" dirty="0">
+                <a:solidFill>
+                  <a:schemeClr val="bg1"/>
+                </a:solidFill>
+              </a:rPr>
+              <a:t> </a:t>
+            </a:r>
+            <a:r>
+              <a:rPr lang="en-US" sz="4500" dirty="0" err="1">
+                <a:solidFill>
+                  <a:schemeClr val="bg1"/>
+                </a:solidFill>
+              </a:rPr>
+              <a:t>ishlash</a:t>
+            </a:r>
+            <a:r>
+              <a:rPr lang="en-US" sz="4500" dirty="0">
+                <a:solidFill>
+                  <a:schemeClr val="bg1"/>
+                </a:solidFill>
+              </a:rPr>
+              <a:t>.</a:t>
+            </a:r>
           </a:p>
         </p:txBody>
       </p:sp>

</xml_diff>